<commit_message>
Make classes optional across the entire course
Reshape Modules 2-5 to a functions-primary + Optional Extension
pattern so classes are never architecturally required. Primary
lesson content, worksheets, exercises, answer keys, and starter/
solution code teach plain functions; each lesson's class-based
refactor becomes an appended "Optional Extension" section (in
lesson docs) or a dedicated addon artifact (slides, code), for
courses that also cover OOP.

Also updates every downstream production artifact to match:
slide outlines, PPTX decks, sketch-style HTML decks, worksheet
HTML renders, and answer-key PDFs across all four modules.

Co-Authored-By: Claude Sonnet 5 <noreply@anthropic.com>
</commit_message>
<xml_diff>
--- a/module-03-grid-driving/slides/01-introduction-to-the-grid.pptx
+++ b/module-03-grid-driving/slides/01-introduction-to-the-grid.pptx
@@ -5,18 +5,18 @@
     <p:sldMasterId id="2147483648" r:id="rId1"/>
   </p:sldMasterIdLst>
   <p:sldIdLst>
-    <p:sldId id="256" r:id="rId2"/>
-    <p:sldId id="257" r:id="rId3"/>
-    <p:sldId id="258" r:id="rId4"/>
-    <p:sldId id="259" r:id="rId5"/>
-    <p:sldId id="260" r:id="rId6"/>
-    <p:sldId id="261" r:id="rId7"/>
-    <p:sldId id="262" r:id="rId8"/>
-    <p:sldId id="263" r:id="rId9"/>
-    <p:sldId id="264" r:id="rId10"/>
-    <p:sldId id="265" r:id="rId11"/>
+    <p:sldId id="256" r:id="rId7"/>
+    <p:sldId id="257" r:id="rId8"/>
+    <p:sldId id="258" r:id="rId9"/>
+    <p:sldId id="259" r:id="rId10"/>
+    <p:sldId id="260" r:id="rId11"/>
+    <p:sldId id="261" r:id="rId12"/>
+    <p:sldId id="262" r:id="rId13"/>
+    <p:sldId id="263" r:id="rId14"/>
+    <p:sldId id="264" r:id="rId15"/>
+    <p:sldId id="265" r:id="rId16"/>
   </p:sldIdLst>
-  <p:sldSz cx="12192000" cy="6858000"/>
+  <p:sldSz cx="12191695" cy="6858000" type="screen4x3"/>
   <p:notesSz cx="6858000" cy="9144000"/>
   <p:defaultTextStyle>
     <a:defPPr>
@@ -113,22 +113,6 @@
       </a:defRPr>
     </a:lvl9pPr>
   </p:defaultTextStyle>
-  <p:extLst>
-    <p:ext uri="{EFAFB233-063F-42B5-8137-9DF3F51BA10A}">
-      <p15:sldGuideLst xmlns:p15="http://schemas.microsoft.com/office/powerpoint/2012/main">
-        <p15:guide id="1" orient="horz" pos="2160">
-          <p15:clr>
-            <a:srgbClr val="A4A3A4"/>
-          </p15:clr>
-        </p15:guide>
-        <p15:guide id="2" pos="2880">
-          <p15:clr>
-            <a:srgbClr val="A4A3A4"/>
-          </p15:clr>
-        </p15:guide>
-      </p15:sldGuideLst>
-    </p:ext>
-  </p:extLst>
 </p:presentation>
 </file>
 
@@ -170,9 +154,10 @@
           <a:lstStyle/>
           <a:p>
             <a:r>
-              <a:rPr lang="en-US"/>
+              <a:rPr lang="en-US" smtClean="0"/>
               <a:t>Click to edit Master title style</a:t>
             </a:r>
+            <a:endParaRPr lang="en-US"/>
           </a:p>
         </p:txBody>
       </p:sp>
@@ -288,9 +273,10 @@
           </a:lstStyle>
           <a:p>
             <a:r>
-              <a:rPr lang="en-US"/>
+              <a:rPr lang="en-US" smtClean="0"/>
               <a:t>Click to edit Master subtitle style</a:t>
             </a:r>
+            <a:endParaRPr lang="en-US"/>
           </a:p>
         </p:txBody>
       </p:sp>
@@ -311,7 +297,7 @@
           <a:p>
             <a:fld id="{5BCAD085-E8A6-8845-BD4E-CB4CCA059FC4}" type="datetimeFigureOut">
               <a:rPr lang="en-US" smtClean="0"/>
-              <a:t>3/20/26</a:t>
+              <a:t>1/27/13</a:t>
             </a:fld>
             <a:endParaRPr lang="en-US"/>
           </a:p>
@@ -405,9 +391,10 @@
           <a:lstStyle/>
           <a:p>
             <a:r>
-              <a:rPr lang="en-US"/>
+              <a:rPr lang="en-US" smtClean="0"/>
               <a:t>Click to edit Master title style</a:t>
             </a:r>
+            <a:endParaRPr lang="en-US"/>
           </a:p>
         </p:txBody>
       </p:sp>
@@ -428,37 +415,38 @@
           <a:p>
             <a:pPr lvl="0"/>
             <a:r>
-              <a:rPr lang="en-US"/>
+              <a:rPr lang="en-US" smtClean="0"/>
               <a:t>Click to edit Master text styles</a:t>
             </a:r>
           </a:p>
           <a:p>
             <a:pPr lvl="1"/>
             <a:r>
-              <a:rPr lang="en-US"/>
+              <a:rPr lang="en-US" smtClean="0"/>
               <a:t>Second level</a:t>
             </a:r>
           </a:p>
           <a:p>
             <a:pPr lvl="2"/>
             <a:r>
-              <a:rPr lang="en-US"/>
+              <a:rPr lang="en-US" smtClean="0"/>
               <a:t>Third level</a:t>
             </a:r>
           </a:p>
           <a:p>
             <a:pPr lvl="3"/>
             <a:r>
-              <a:rPr lang="en-US"/>
+              <a:rPr lang="en-US" smtClean="0"/>
               <a:t>Fourth level</a:t>
             </a:r>
           </a:p>
           <a:p>
             <a:pPr lvl="4"/>
             <a:r>
-              <a:rPr lang="en-US"/>
+              <a:rPr lang="en-US" smtClean="0"/>
               <a:t>Fifth level</a:t>
             </a:r>
+            <a:endParaRPr lang="en-US"/>
           </a:p>
         </p:txBody>
       </p:sp>
@@ -479,7 +467,7 @@
           <a:p>
             <a:fld id="{5BCAD085-E8A6-8845-BD4E-CB4CCA059FC4}" type="datetimeFigureOut">
               <a:rPr lang="en-US" smtClean="0"/>
-              <a:t>3/20/26</a:t>
+              <a:t>1/27/13</a:t>
             </a:fld>
             <a:endParaRPr lang="en-US"/>
           </a:p>
@@ -578,9 +566,10 @@
           <a:lstStyle/>
           <a:p>
             <a:r>
-              <a:rPr lang="en-US"/>
+              <a:rPr lang="en-US" smtClean="0"/>
               <a:t>Click to edit Master title style</a:t>
             </a:r>
+            <a:endParaRPr lang="en-US"/>
           </a:p>
         </p:txBody>
       </p:sp>
@@ -606,37 +595,38 @@
           <a:p>
             <a:pPr lvl="0"/>
             <a:r>
-              <a:rPr lang="en-US"/>
+              <a:rPr lang="en-US" smtClean="0"/>
               <a:t>Click to edit Master text styles</a:t>
             </a:r>
           </a:p>
           <a:p>
             <a:pPr lvl="1"/>
             <a:r>
-              <a:rPr lang="en-US"/>
+              <a:rPr lang="en-US" smtClean="0"/>
               <a:t>Second level</a:t>
             </a:r>
           </a:p>
           <a:p>
             <a:pPr lvl="2"/>
             <a:r>
-              <a:rPr lang="en-US"/>
+              <a:rPr lang="en-US" smtClean="0"/>
               <a:t>Third level</a:t>
             </a:r>
           </a:p>
           <a:p>
             <a:pPr lvl="3"/>
             <a:r>
-              <a:rPr lang="en-US"/>
+              <a:rPr lang="en-US" smtClean="0"/>
               <a:t>Fourth level</a:t>
             </a:r>
           </a:p>
           <a:p>
             <a:pPr lvl="4"/>
             <a:r>
-              <a:rPr lang="en-US"/>
+              <a:rPr lang="en-US" smtClean="0"/>
               <a:t>Fifth level</a:t>
             </a:r>
+            <a:endParaRPr lang="en-US"/>
           </a:p>
         </p:txBody>
       </p:sp>
@@ -657,7 +647,7 @@
           <a:p>
             <a:fld id="{5BCAD085-E8A6-8845-BD4E-CB4CCA059FC4}" type="datetimeFigureOut">
               <a:rPr lang="en-US" smtClean="0"/>
-              <a:t>3/20/26</a:t>
+              <a:t>1/27/13</a:t>
             </a:fld>
             <a:endParaRPr lang="en-US"/>
           </a:p>
@@ -751,9 +741,10 @@
           <a:lstStyle/>
           <a:p>
             <a:r>
-              <a:rPr lang="en-US"/>
+              <a:rPr lang="en-US" smtClean="0"/>
               <a:t>Click to edit Master title style</a:t>
             </a:r>
+            <a:endParaRPr lang="en-US"/>
           </a:p>
         </p:txBody>
       </p:sp>
@@ -774,37 +765,38 @@
           <a:p>
             <a:pPr lvl="0"/>
             <a:r>
-              <a:rPr lang="en-US"/>
+              <a:rPr lang="en-US" smtClean="0"/>
               <a:t>Click to edit Master text styles</a:t>
             </a:r>
           </a:p>
           <a:p>
             <a:pPr lvl="1"/>
             <a:r>
-              <a:rPr lang="en-US"/>
+              <a:rPr lang="en-US" smtClean="0"/>
               <a:t>Second level</a:t>
             </a:r>
           </a:p>
           <a:p>
             <a:pPr lvl="2"/>
             <a:r>
-              <a:rPr lang="en-US"/>
+              <a:rPr lang="en-US" smtClean="0"/>
               <a:t>Third level</a:t>
             </a:r>
           </a:p>
           <a:p>
             <a:pPr lvl="3"/>
             <a:r>
-              <a:rPr lang="en-US"/>
+              <a:rPr lang="en-US" smtClean="0"/>
               <a:t>Fourth level</a:t>
             </a:r>
           </a:p>
           <a:p>
             <a:pPr lvl="4"/>
             <a:r>
-              <a:rPr lang="en-US"/>
+              <a:rPr lang="en-US" smtClean="0"/>
               <a:t>Fifth level</a:t>
             </a:r>
+            <a:endParaRPr lang="en-US"/>
           </a:p>
         </p:txBody>
       </p:sp>
@@ -825,7 +817,7 @@
           <a:p>
             <a:fld id="{5BCAD085-E8A6-8845-BD4E-CB4CCA059FC4}" type="datetimeFigureOut">
               <a:rPr lang="en-US" smtClean="0"/>
-              <a:t>3/20/26</a:t>
+              <a:t>1/27/13</a:t>
             </a:fld>
             <a:endParaRPr lang="en-US"/>
           </a:p>
@@ -928,9 +920,10 @@
           </a:lstStyle>
           <a:p>
             <a:r>
-              <a:rPr lang="en-US"/>
+              <a:rPr lang="en-US" smtClean="0"/>
               <a:t>Click to edit Master title style</a:t>
             </a:r>
+            <a:endParaRPr lang="en-US"/>
           </a:p>
         </p:txBody>
       </p:sp>
@@ -1047,7 +1040,7 @@
           <a:p>
             <a:pPr lvl="0"/>
             <a:r>
-              <a:rPr lang="en-US"/>
+              <a:rPr lang="en-US" smtClean="0"/>
               <a:t>Click to edit Master text styles</a:t>
             </a:r>
           </a:p>
@@ -1070,7 +1063,7 @@
           <a:p>
             <a:fld id="{5BCAD085-E8A6-8845-BD4E-CB4CCA059FC4}" type="datetimeFigureOut">
               <a:rPr lang="en-US" smtClean="0"/>
-              <a:t>3/20/26</a:t>
+              <a:t>1/27/13</a:t>
             </a:fld>
             <a:endParaRPr lang="en-US"/>
           </a:p>
@@ -1164,9 +1157,10 @@
           <a:lstStyle/>
           <a:p>
             <a:r>
-              <a:rPr lang="en-US"/>
+              <a:rPr lang="en-US" smtClean="0"/>
               <a:t>Click to edit Master title style</a:t>
             </a:r>
+            <a:endParaRPr lang="en-US"/>
           </a:p>
         </p:txBody>
       </p:sp>
@@ -1220,37 +1214,38 @@
           <a:p>
             <a:pPr lvl="0"/>
             <a:r>
-              <a:rPr lang="en-US"/>
+              <a:rPr lang="en-US" smtClean="0"/>
               <a:t>Click to edit Master text styles</a:t>
             </a:r>
           </a:p>
           <a:p>
             <a:pPr lvl="1"/>
             <a:r>
-              <a:rPr lang="en-US"/>
+              <a:rPr lang="en-US" smtClean="0"/>
               <a:t>Second level</a:t>
             </a:r>
           </a:p>
           <a:p>
             <a:pPr lvl="2"/>
             <a:r>
-              <a:rPr lang="en-US"/>
+              <a:rPr lang="en-US" smtClean="0"/>
               <a:t>Third level</a:t>
             </a:r>
           </a:p>
           <a:p>
             <a:pPr lvl="3"/>
             <a:r>
-              <a:rPr lang="en-US"/>
+              <a:rPr lang="en-US" smtClean="0"/>
               <a:t>Fourth level</a:t>
             </a:r>
           </a:p>
           <a:p>
             <a:pPr lvl="4"/>
             <a:r>
-              <a:rPr lang="en-US"/>
+              <a:rPr lang="en-US" smtClean="0"/>
               <a:t>Fifth level</a:t>
             </a:r>
+            <a:endParaRPr lang="en-US"/>
           </a:p>
         </p:txBody>
       </p:sp>
@@ -1304,37 +1299,38 @@
           <a:p>
             <a:pPr lvl="0"/>
             <a:r>
-              <a:rPr lang="en-US"/>
+              <a:rPr lang="en-US" smtClean="0"/>
               <a:t>Click to edit Master text styles</a:t>
             </a:r>
           </a:p>
           <a:p>
             <a:pPr lvl="1"/>
             <a:r>
-              <a:rPr lang="en-US"/>
+              <a:rPr lang="en-US" smtClean="0"/>
               <a:t>Second level</a:t>
             </a:r>
           </a:p>
           <a:p>
             <a:pPr lvl="2"/>
             <a:r>
-              <a:rPr lang="en-US"/>
+              <a:rPr lang="en-US" smtClean="0"/>
               <a:t>Third level</a:t>
             </a:r>
           </a:p>
           <a:p>
             <a:pPr lvl="3"/>
             <a:r>
-              <a:rPr lang="en-US"/>
+              <a:rPr lang="en-US" smtClean="0"/>
               <a:t>Fourth level</a:t>
             </a:r>
           </a:p>
           <a:p>
             <a:pPr lvl="4"/>
             <a:r>
-              <a:rPr lang="en-US"/>
+              <a:rPr lang="en-US" smtClean="0"/>
               <a:t>Fifth level</a:t>
             </a:r>
+            <a:endParaRPr lang="en-US"/>
           </a:p>
         </p:txBody>
       </p:sp>
@@ -1355,7 +1351,7 @@
           <a:p>
             <a:fld id="{5BCAD085-E8A6-8845-BD4E-CB4CCA059FC4}" type="datetimeFigureOut">
               <a:rPr lang="en-US" smtClean="0"/>
-              <a:t>3/20/26</a:t>
+              <a:t>1/27/13</a:t>
             </a:fld>
             <a:endParaRPr lang="en-US"/>
           </a:p>
@@ -1453,9 +1449,10 @@
           </a:lstStyle>
           <a:p>
             <a:r>
-              <a:rPr lang="en-US"/>
+              <a:rPr lang="en-US" smtClean="0"/>
               <a:t>Click to edit Master title style</a:t>
             </a:r>
+            <a:endParaRPr lang="en-US"/>
           </a:p>
         </p:txBody>
       </p:sp>
@@ -1518,7 +1515,7 @@
           <a:p>
             <a:pPr lvl="0"/>
             <a:r>
-              <a:rPr lang="en-US"/>
+              <a:rPr lang="en-US" smtClean="0"/>
               <a:t>Click to edit Master text styles</a:t>
             </a:r>
           </a:p>
@@ -1574,37 +1571,38 @@
           <a:p>
             <a:pPr lvl="0"/>
             <a:r>
-              <a:rPr lang="en-US"/>
+              <a:rPr lang="en-US" smtClean="0"/>
               <a:t>Click to edit Master text styles</a:t>
             </a:r>
           </a:p>
           <a:p>
             <a:pPr lvl="1"/>
             <a:r>
-              <a:rPr lang="en-US"/>
+              <a:rPr lang="en-US" smtClean="0"/>
               <a:t>Second level</a:t>
             </a:r>
           </a:p>
           <a:p>
             <a:pPr lvl="2"/>
             <a:r>
-              <a:rPr lang="en-US"/>
+              <a:rPr lang="en-US" smtClean="0"/>
               <a:t>Third level</a:t>
             </a:r>
           </a:p>
           <a:p>
             <a:pPr lvl="3"/>
             <a:r>
-              <a:rPr lang="en-US"/>
+              <a:rPr lang="en-US" smtClean="0"/>
               <a:t>Fourth level</a:t>
             </a:r>
           </a:p>
           <a:p>
             <a:pPr lvl="4"/>
             <a:r>
-              <a:rPr lang="en-US"/>
+              <a:rPr lang="en-US" smtClean="0"/>
               <a:t>Fifth level</a:t>
             </a:r>
+            <a:endParaRPr lang="en-US"/>
           </a:p>
         </p:txBody>
       </p:sp>
@@ -1667,7 +1665,7 @@
           <a:p>
             <a:pPr lvl="0"/>
             <a:r>
-              <a:rPr lang="en-US"/>
+              <a:rPr lang="en-US" smtClean="0"/>
               <a:t>Click to edit Master text styles</a:t>
             </a:r>
           </a:p>
@@ -1723,37 +1721,38 @@
           <a:p>
             <a:pPr lvl="0"/>
             <a:r>
-              <a:rPr lang="en-US"/>
+              <a:rPr lang="en-US" smtClean="0"/>
               <a:t>Click to edit Master text styles</a:t>
             </a:r>
           </a:p>
           <a:p>
             <a:pPr lvl="1"/>
             <a:r>
-              <a:rPr lang="en-US"/>
+              <a:rPr lang="en-US" smtClean="0"/>
               <a:t>Second level</a:t>
             </a:r>
           </a:p>
           <a:p>
             <a:pPr lvl="2"/>
             <a:r>
-              <a:rPr lang="en-US"/>
+              <a:rPr lang="en-US" smtClean="0"/>
               <a:t>Third level</a:t>
             </a:r>
           </a:p>
           <a:p>
             <a:pPr lvl="3"/>
             <a:r>
-              <a:rPr lang="en-US"/>
+              <a:rPr lang="en-US" smtClean="0"/>
               <a:t>Fourth level</a:t>
             </a:r>
           </a:p>
           <a:p>
             <a:pPr lvl="4"/>
             <a:r>
-              <a:rPr lang="en-US"/>
+              <a:rPr lang="en-US" smtClean="0"/>
               <a:t>Fifth level</a:t>
             </a:r>
+            <a:endParaRPr lang="en-US"/>
           </a:p>
         </p:txBody>
       </p:sp>
@@ -1774,7 +1773,7 @@
           <a:p>
             <a:fld id="{5BCAD085-E8A6-8845-BD4E-CB4CCA059FC4}" type="datetimeFigureOut">
               <a:rPr lang="en-US" smtClean="0"/>
-              <a:t>3/20/26</a:t>
+              <a:t>1/27/13</a:t>
             </a:fld>
             <a:endParaRPr lang="en-US"/>
           </a:p>
@@ -1868,9 +1867,10 @@
           <a:lstStyle/>
           <a:p>
             <a:r>
-              <a:rPr lang="en-US"/>
+              <a:rPr lang="en-US" smtClean="0"/>
               <a:t>Click to edit Master title style</a:t>
             </a:r>
+            <a:endParaRPr lang="en-US"/>
           </a:p>
         </p:txBody>
       </p:sp>
@@ -1891,7 +1891,7 @@
           <a:p>
             <a:fld id="{5BCAD085-E8A6-8845-BD4E-CB4CCA059FC4}" type="datetimeFigureOut">
               <a:rPr lang="en-US" smtClean="0"/>
-              <a:t>3/20/26</a:t>
+              <a:t>1/27/13</a:t>
             </a:fld>
             <a:endParaRPr lang="en-US"/>
           </a:p>
@@ -1986,7 +1986,7 @@
           <a:p>
             <a:fld id="{5BCAD085-E8A6-8845-BD4E-CB4CCA059FC4}" type="datetimeFigureOut">
               <a:rPr lang="en-US" smtClean="0"/>
-              <a:t>3/20/26</a:t>
+              <a:t>1/27/13</a:t>
             </a:fld>
             <a:endParaRPr lang="en-US"/>
           </a:p>
@@ -2089,9 +2089,10 @@
           </a:lstStyle>
           <a:p>
             <a:r>
-              <a:rPr lang="en-US"/>
+              <a:rPr lang="en-US" smtClean="0"/>
               <a:t>Click to edit Master title style</a:t>
             </a:r>
+            <a:endParaRPr lang="en-US"/>
           </a:p>
         </p:txBody>
       </p:sp>
@@ -2145,37 +2146,38 @@
           <a:p>
             <a:pPr lvl="0"/>
             <a:r>
-              <a:rPr lang="en-US"/>
+              <a:rPr lang="en-US" smtClean="0"/>
               <a:t>Click to edit Master text styles</a:t>
             </a:r>
           </a:p>
           <a:p>
             <a:pPr lvl="1"/>
             <a:r>
-              <a:rPr lang="en-US"/>
+              <a:rPr lang="en-US" smtClean="0"/>
               <a:t>Second level</a:t>
             </a:r>
           </a:p>
           <a:p>
             <a:pPr lvl="2"/>
             <a:r>
-              <a:rPr lang="en-US"/>
+              <a:rPr lang="en-US" smtClean="0"/>
               <a:t>Third level</a:t>
             </a:r>
           </a:p>
           <a:p>
             <a:pPr lvl="3"/>
             <a:r>
-              <a:rPr lang="en-US"/>
+              <a:rPr lang="en-US" smtClean="0"/>
               <a:t>Fourth level</a:t>
             </a:r>
           </a:p>
           <a:p>
             <a:pPr lvl="4"/>
             <a:r>
-              <a:rPr lang="en-US"/>
+              <a:rPr lang="en-US" smtClean="0"/>
               <a:t>Fifth level</a:t>
             </a:r>
+            <a:endParaRPr lang="en-US"/>
           </a:p>
         </p:txBody>
       </p:sp>
@@ -2238,7 +2240,7 @@
           <a:p>
             <a:pPr lvl="0"/>
             <a:r>
-              <a:rPr lang="en-US"/>
+              <a:rPr lang="en-US" smtClean="0"/>
               <a:t>Click to edit Master text styles</a:t>
             </a:r>
           </a:p>
@@ -2261,7 +2263,7 @@
           <a:p>
             <a:fld id="{5BCAD085-E8A6-8845-BD4E-CB4CCA059FC4}" type="datetimeFigureOut">
               <a:rPr lang="en-US" smtClean="0"/>
-              <a:t>3/20/26</a:t>
+              <a:t>1/27/13</a:t>
             </a:fld>
             <a:endParaRPr lang="en-US"/>
           </a:p>
@@ -2364,9 +2366,10 @@
           </a:lstStyle>
           <a:p>
             <a:r>
-              <a:rPr lang="en-US"/>
+              <a:rPr lang="en-US" smtClean="0"/>
               <a:t>Click to edit Master title style</a:t>
             </a:r>
+            <a:endParaRPr lang="en-US"/>
           </a:p>
         </p:txBody>
       </p:sp>
@@ -2490,7 +2493,7 @@
           <a:p>
             <a:pPr lvl="0"/>
             <a:r>
-              <a:rPr lang="en-US"/>
+              <a:rPr lang="en-US" smtClean="0"/>
               <a:t>Click to edit Master text styles</a:t>
             </a:r>
           </a:p>
@@ -2513,7 +2516,7 @@
           <a:p>
             <a:fld id="{5BCAD085-E8A6-8845-BD4E-CB4CCA059FC4}" type="datetimeFigureOut">
               <a:rPr lang="en-US" smtClean="0"/>
-              <a:t>3/20/26</a:t>
+              <a:t>1/27/13</a:t>
             </a:fld>
             <a:endParaRPr lang="en-US"/>
           </a:p>
@@ -2622,9 +2625,10 @@
           <a:lstStyle/>
           <a:p>
             <a:r>
-              <a:rPr lang="en-US"/>
+              <a:rPr lang="en-US" smtClean="0"/>
               <a:t>Click to edit Master title style</a:t>
             </a:r>
+            <a:endParaRPr lang="en-US"/>
           </a:p>
         </p:txBody>
       </p:sp>
@@ -2655,37 +2659,38 @@
           <a:p>
             <a:pPr lvl="0"/>
             <a:r>
-              <a:rPr lang="en-US"/>
+              <a:rPr lang="en-US" smtClean="0"/>
               <a:t>Click to edit Master text styles</a:t>
             </a:r>
           </a:p>
           <a:p>
             <a:pPr lvl="1"/>
             <a:r>
-              <a:rPr lang="en-US"/>
+              <a:rPr lang="en-US" smtClean="0"/>
               <a:t>Second level</a:t>
             </a:r>
           </a:p>
           <a:p>
             <a:pPr lvl="2"/>
             <a:r>
-              <a:rPr lang="en-US"/>
+              <a:rPr lang="en-US" smtClean="0"/>
               <a:t>Third level</a:t>
             </a:r>
           </a:p>
           <a:p>
             <a:pPr lvl="3"/>
             <a:r>
-              <a:rPr lang="en-US"/>
+              <a:rPr lang="en-US" smtClean="0"/>
               <a:t>Fourth level</a:t>
             </a:r>
           </a:p>
           <a:p>
             <a:pPr lvl="4"/>
             <a:r>
-              <a:rPr lang="en-US"/>
+              <a:rPr lang="en-US" smtClean="0"/>
               <a:t>Fifth level</a:t>
             </a:r>
+            <a:endParaRPr lang="en-US"/>
           </a:p>
         </p:txBody>
       </p:sp>
@@ -2724,7 +2729,7 @@
           <a:p>
             <a:fld id="{5BCAD085-E8A6-8845-BD4E-CB4CCA059FC4}" type="datetimeFigureOut">
               <a:rPr lang="en-US" smtClean="0"/>
-              <a:t>3/20/26</a:t>
+              <a:t>1/27/13</a:t>
             </a:fld>
             <a:endParaRPr lang="en-US"/>
           </a:p>
@@ -3083,7 +3088,7 @@
 </file>
 
 <file path=ppt/slides/slide1.xml><?xml version="1.0" encoding="utf-8"?>
-<p:sld xmlns:a="http://schemas.openxmlformats.org/drawingml/2006/main" xmlns:r="http://schemas.openxmlformats.org/officeDocument/2006/relationships" xmlns:p="http://schemas.openxmlformats.org/presentationml/2006/main">
+<p:sld xmlns:a="http://schemas.openxmlformats.org/drawingml/2006/main" xmlns:p="http://schemas.openxmlformats.org/presentationml/2006/main" xmlns:r="http://schemas.openxmlformats.org/officeDocument/2006/relationships">
   <p:cSld>
     <p:spTree>
       <p:nvGrpSpPr>
@@ -3091,14 +3096,7 @@
         <p:cNvGrpSpPr/>
         <p:nvPr/>
       </p:nvGrpSpPr>
-      <p:grpSpPr>
-        <a:xfrm>
-          <a:off x="0" y="0"/>
-          <a:ext cx="0" cy="0"/>
-          <a:chOff x="0" y="0"/>
-          <a:chExt cx="0" cy="0"/>
-        </a:xfrm>
-      </p:grpSpPr>
+      <p:grpSpPr/>
       <p:sp>
         <p:nvSpPr>
           <p:cNvPr id="2" name="Rectangle 1"/>
@@ -3139,7 +3137,6 @@
           <a:lstStyle/>
           <a:p>
             <a:pPr algn="ctr"/>
-            <a:endParaRPr/>
           </a:p>
         </p:txBody>
       </p:sp>
@@ -3294,7 +3291,7 @@
               </a:defRPr>
             </a:pPr>
             <a:r>
-              <a:t>Use the LineTrack class to drive to the first intersection</a:t>
+              <a:t>Use the driving toolkit to drive to the first intersection</a:t>
             </a:r>
           </a:p>
           <a:p>
@@ -3378,7 +3375,7 @@
               </a:defRPr>
             </a:pPr>
             <a:r>
-              <a:t>Review: LineTrack methods (5 min)</a:t>
+              <a:t>Review: driving toolkit functions (5 min)</a:t>
             </a:r>
           </a:p>
           <a:p>
@@ -3424,7 +3421,7 @@
 </file>
 
 <file path=ppt/slides/slide10.xml><?xml version="1.0" encoding="utf-8"?>
-<p:sld xmlns:a="http://schemas.openxmlformats.org/drawingml/2006/main" xmlns:r="http://schemas.openxmlformats.org/officeDocument/2006/relationships" xmlns:p="http://schemas.openxmlformats.org/presentationml/2006/main">
+<p:sld xmlns:a="http://schemas.openxmlformats.org/drawingml/2006/main" xmlns:p="http://schemas.openxmlformats.org/presentationml/2006/main" xmlns:r="http://schemas.openxmlformats.org/officeDocument/2006/relationships">
   <p:cSld>
     <p:spTree>
       <p:nvGrpSpPr>
@@ -3432,14 +3429,7 @@
         <p:cNvGrpSpPr/>
         <p:nvPr/>
       </p:nvGrpSpPr>
-      <p:grpSpPr>
-        <a:xfrm>
-          <a:off x="0" y="0"/>
-          <a:ext cx="0" cy="0"/>
-          <a:chOff x="0" y="0"/>
-          <a:chExt cx="0" cy="0"/>
-        </a:xfrm>
-      </p:grpSpPr>
+      <p:grpSpPr/>
       <p:sp>
         <p:nvSpPr>
           <p:cNvPr id="2" name="Rectangle 1"/>
@@ -3480,7 +3470,6 @@
           <a:lstStyle/>
           <a:p>
             <a:pPr algn="ctr"/>
-            <a:endParaRPr/>
           </a:p>
         </p:txBody>
       </p:sp>
@@ -3586,7 +3575,7 @@
               </a:defRPr>
             </a:pPr>
             <a:r>
-              <a:t>Drove to the first intersection using LineTrack</a:t>
+              <a:t>Drove to the first intersection using the driving toolkit</a:t>
             </a:r>
           </a:p>
           <a:p>
@@ -3617,7 +3606,6 @@
                 <a:latin typeface="Calibri"/>
               </a:defRPr>
             </a:pPr>
-            <a:endParaRPr/>
           </a:p>
           <a:p>
             <a:pPr>
@@ -3695,7 +3683,6 @@
                 <a:latin typeface="Calibri"/>
               </a:defRPr>
             </a:pPr>
-            <a:endParaRPr/>
           </a:p>
           <a:p>
             <a:pPr>
@@ -3724,7 +3711,7 @@
 </file>
 
 <file path=ppt/slides/slide2.xml><?xml version="1.0" encoding="utf-8"?>
-<p:sld xmlns:a="http://schemas.openxmlformats.org/drawingml/2006/main" xmlns:r="http://schemas.openxmlformats.org/officeDocument/2006/relationships" xmlns:p="http://schemas.openxmlformats.org/presentationml/2006/main">
+<p:sld xmlns:a="http://schemas.openxmlformats.org/drawingml/2006/main" xmlns:p="http://schemas.openxmlformats.org/presentationml/2006/main" xmlns:r="http://schemas.openxmlformats.org/officeDocument/2006/relationships">
   <p:cSld>
     <p:spTree>
       <p:nvGrpSpPr>
@@ -3732,14 +3719,7 @@
         <p:cNvGrpSpPr/>
         <p:nvPr/>
       </p:nvGrpSpPr>
-      <p:grpSpPr>
-        <a:xfrm>
-          <a:off x="0" y="0"/>
-          <a:ext cx="0" cy="0"/>
-          <a:chOff x="0" y="0"/>
-          <a:chExt cx="0" cy="0"/>
-        </a:xfrm>
-      </p:grpSpPr>
+      <p:grpSpPr/>
       <p:sp>
         <p:nvSpPr>
           <p:cNvPr id="2" name="Rectangle 1"/>
@@ -3780,7 +3760,6 @@
           <a:lstStyle/>
           <a:p>
             <a:pPr algn="ctr"/>
-            <a:endParaRPr/>
           </a:p>
         </p:txBody>
       </p:sp>
@@ -3870,7 +3849,7 @@
               </a:defRPr>
             </a:pPr>
             <a:r>
-              <a:t>You built a LineTrack class that follows lines and detects crosses</a:t>
+              <a:t>You built a driving toolkit that follows lines and detects crosses</a:t>
             </a:r>
           </a:p>
           <a:p>
@@ -3885,7 +3864,6 @@
                 <a:latin typeface="Calibri"/>
               </a:defRPr>
             </a:pPr>
-            <a:endParaRPr/>
           </a:p>
           <a:p>
             <a:pPr>
@@ -3963,7 +3941,6 @@
                 <a:latin typeface="Calibri"/>
               </a:defRPr>
             </a:pPr>
-            <a:endParaRPr/>
           </a:p>
           <a:p>
             <a:pPr>
@@ -3993,7 +3970,6 @@
                 <a:latin typeface="Calibri"/>
               </a:defRPr>
             </a:pPr>
-            <a:endParaRPr/>
           </a:p>
           <a:p>
             <a:pPr>
@@ -4023,7 +3999,6 @@
                 <a:latin typeface="Calibri"/>
               </a:defRPr>
             </a:pPr>
-            <a:endParaRPr/>
           </a:p>
         </p:txBody>
       </p:sp>
@@ -4036,7 +4011,7 @@
 </file>
 
 <file path=ppt/slides/slide3.xml><?xml version="1.0" encoding="utf-8"?>
-<p:sld xmlns:a="http://schemas.openxmlformats.org/drawingml/2006/main" xmlns:r="http://schemas.openxmlformats.org/officeDocument/2006/relationships" xmlns:p="http://schemas.openxmlformats.org/presentationml/2006/main">
+<p:sld xmlns:a="http://schemas.openxmlformats.org/drawingml/2006/main" xmlns:p="http://schemas.openxmlformats.org/presentationml/2006/main" xmlns:r="http://schemas.openxmlformats.org/officeDocument/2006/relationships">
   <p:cSld>
     <p:spTree>
       <p:nvGrpSpPr>
@@ -4044,14 +4019,7 @@
         <p:cNvGrpSpPr/>
         <p:nvPr/>
       </p:nvGrpSpPr>
-      <p:grpSpPr>
-        <a:xfrm>
-          <a:off x="0" y="0"/>
-          <a:ext cx="0" cy="0"/>
-          <a:chOff x="0" y="0"/>
-          <a:chExt cx="0" cy="0"/>
-        </a:xfrm>
-      </p:grpSpPr>
+      <p:grpSpPr/>
       <p:sp>
         <p:nvSpPr>
           <p:cNvPr id="2" name="Rectangle 1"/>
@@ -4092,7 +4060,6 @@
           <a:lstStyle/>
           <a:p>
             <a:pPr algn="ctr"/>
-            <a:endParaRPr/>
           </a:p>
         </p:txBody>
       </p:sp>
@@ -4181,7 +4148,6 @@
                 <a:latin typeface="Calibri"/>
               </a:defRPr>
             </a:pPr>
-            <a:endParaRPr/>
           </a:p>
         </p:txBody>
       </p:sp>
@@ -4191,16 +4157,10 @@
           <p:cNvGraphicFramePr>
             <a:graphicFrameLocks noGrp="1"/>
           </p:cNvGraphicFramePr>
-          <p:nvPr>
-            <p:extLst>
-              <p:ext uri="{D42A27DB-BD31-4B8C-83A1-F6EECF244321}">
-                <p14:modId xmlns:p14="http://schemas.microsoft.com/office/powerpoint/2010/main" val="2354120848"/>
-              </p:ext>
-            </p:extLst>
-          </p:nvPr>
+          <p:nvPr/>
         </p:nvGraphicFramePr>
         <p:xfrm>
-          <a:off x="548640" y="1869204"/>
+          <a:off x="914400" y="1371600"/>
           <a:ext cx="10058400" cy="1828800"/>
         </p:xfrm>
         <a:graphic>
@@ -4210,41 +4170,11 @@
                 <a:tableStyleId>{5C22544A-7EE6-4342-B048-85BDC9FD1C3A}</a:tableStyleId>
               </a:tblPr>
               <a:tblGrid>
-                <a:gridCol w="2011680">
-                  <a:extLst>
-                    <a:ext uri="{9D8B030D-6E8A-4147-A177-3AD203B41FA5}">
-                      <a16:colId xmlns:a16="http://schemas.microsoft.com/office/drawing/2014/main" val="20000"/>
-                    </a:ext>
-                  </a:extLst>
-                </a:gridCol>
-                <a:gridCol w="2011680">
-                  <a:extLst>
-                    <a:ext uri="{9D8B030D-6E8A-4147-A177-3AD203B41FA5}">
-                      <a16:colId xmlns:a16="http://schemas.microsoft.com/office/drawing/2014/main" val="20001"/>
-                    </a:ext>
-                  </a:extLst>
-                </a:gridCol>
-                <a:gridCol w="2011680">
-                  <a:extLst>
-                    <a:ext uri="{9D8B030D-6E8A-4147-A177-3AD203B41FA5}">
-                      <a16:colId xmlns:a16="http://schemas.microsoft.com/office/drawing/2014/main" val="20002"/>
-                    </a:ext>
-                  </a:extLst>
-                </a:gridCol>
-                <a:gridCol w="2011680">
-                  <a:extLst>
-                    <a:ext uri="{9D8B030D-6E8A-4147-A177-3AD203B41FA5}">
-                      <a16:colId xmlns:a16="http://schemas.microsoft.com/office/drawing/2014/main" val="20003"/>
-                    </a:ext>
-                  </a:extLst>
-                </a:gridCol>
-                <a:gridCol w="2011680">
-                  <a:extLst>
-                    <a:ext uri="{9D8B030D-6E8A-4147-A177-3AD203B41FA5}">
-                      <a16:colId xmlns:a16="http://schemas.microsoft.com/office/drawing/2014/main" val="20004"/>
-                    </a:ext>
-                  </a:extLst>
-                </a:gridCol>
+                <a:gridCol w="2011680"/>
+                <a:gridCol w="2011680"/>
+                <a:gridCol w="2011680"/>
+                <a:gridCol w="2011680"/>
+                <a:gridCol w="2011680"/>
               </a:tblGrid>
               <a:tr h="365760">
                 <a:tc>
@@ -4260,7 +4190,6 @@
                           <a:latin typeface="Calibri"/>
                         </a:defRPr>
                       </a:pPr>
-                      <a:endParaRPr/>
                     </a:p>
                   </a:txBody>
                   <a:tcPr>
@@ -4365,11 +4294,6 @@
                     </a:solidFill>
                   </a:tcPr>
                 </a:tc>
-                <a:extLst>
-                  <a:ext uri="{0D108BD9-81ED-4DB2-BD59-A6C34878D82A}">
-                    <a16:rowId xmlns:a16="http://schemas.microsoft.com/office/drawing/2014/main" val="10000"/>
-                  </a:ext>
-                </a:extLst>
               </a:tr>
               <a:tr h="365760">
                 <a:tc>
@@ -4457,11 +4381,6 @@
                   </a:txBody>
                   <a:tcPr/>
                 </a:tc>
-                <a:extLst>
-                  <a:ext uri="{0D108BD9-81ED-4DB2-BD59-A6C34878D82A}">
-                    <a16:rowId xmlns:a16="http://schemas.microsoft.com/office/drawing/2014/main" val="10001"/>
-                  </a:ext>
-                </a:extLst>
               </a:tr>
               <a:tr h="365760">
                 <a:tc>
@@ -4569,11 +4488,6 @@
                     </a:solidFill>
                   </a:tcPr>
                 </a:tc>
-                <a:extLst>
-                  <a:ext uri="{0D108BD9-81ED-4DB2-BD59-A6C34878D82A}">
-                    <a16:rowId xmlns:a16="http://schemas.microsoft.com/office/drawing/2014/main" val="10002"/>
-                  </a:ext>
-                </a:extLst>
               </a:tr>
               <a:tr h="365760">
                 <a:tc>
@@ -4661,11 +4575,6 @@
                   </a:txBody>
                   <a:tcPr/>
                 </a:tc>
-                <a:extLst>
-                  <a:ext uri="{0D108BD9-81ED-4DB2-BD59-A6C34878D82A}">
-                    <a16:rowId xmlns:a16="http://schemas.microsoft.com/office/drawing/2014/main" val="10003"/>
-                  </a:ext>
-                </a:extLst>
               </a:tr>
               <a:tr h="365760">
                 <a:tc>
@@ -4700,7 +4609,6 @@
                         </a:defRPr>
                       </a:pPr>
                       <a:r>
-                        <a:rPr dirty="0"/>
                         <a:t>+</a:t>
                       </a:r>
                     </a:p>
@@ -4764,7 +4672,6 @@
                         </a:defRPr>
                       </a:pPr>
                       <a:r>
-                        <a:rPr dirty="0"/>
                         <a:t>+</a:t>
                       </a:r>
                     </a:p>
@@ -4775,11 +4682,6 @@
                     </a:solidFill>
                   </a:tcPr>
                 </a:tc>
-                <a:extLst>
-                  <a:ext uri="{0D108BD9-81ED-4DB2-BD59-A6C34878D82A}">
-                    <a16:rowId xmlns:a16="http://schemas.microsoft.com/office/drawing/2014/main" val="10004"/>
-                  </a:ext>
-                </a:extLst>
               </a:tr>
             </a:tbl>
           </a:graphicData>
@@ -4793,7 +4695,7 @@
         </p:nvSpPr>
         <p:spPr>
           <a:xfrm>
-            <a:off x="548640" y="3829848"/>
+            <a:off x="548640" y="3383280"/>
             <a:ext cx="10972800" cy="365760"/>
           </a:xfrm>
           <a:prstGeom prst="rect">
@@ -4819,7 +4721,6 @@
               </a:defRPr>
             </a:pPr>
             <a:r>
-              <a:rPr dirty="0"/>
               <a:t>Each "+" is an intersection:</a:t>
             </a:r>
           </a:p>
@@ -4836,7 +4737,6 @@
               </a:defRPr>
             </a:pPr>
             <a:r>
-              <a:rPr dirty="0"/>
               <a:t>Lines connecting them horizontally and vertically</a:t>
             </a:r>
           </a:p>
@@ -4853,7 +4753,6 @@
               </a:defRPr>
             </a:pPr>
             <a:r>
-              <a:rPr dirty="0"/>
               <a:t>The robot follows lines between intersections</a:t>
             </a:r>
           </a:p>
@@ -4870,7 +4769,6 @@
               </a:defRPr>
             </a:pPr>
             <a:r>
-              <a:rPr dirty="0"/>
               <a:t>Cross detection tells the robot it has arrived</a:t>
             </a:r>
           </a:p>
@@ -4886,7 +4784,6 @@
                 <a:latin typeface="Calibri"/>
               </a:defRPr>
             </a:pPr>
-            <a:endParaRPr dirty="0"/>
           </a:p>
         </p:txBody>
       </p:sp>
@@ -4899,7 +4796,7 @@
 </file>
 
 <file path=ppt/slides/slide4.xml><?xml version="1.0" encoding="utf-8"?>
-<p:sld xmlns:a="http://schemas.openxmlformats.org/drawingml/2006/main" xmlns:r="http://schemas.openxmlformats.org/officeDocument/2006/relationships" xmlns:p="http://schemas.openxmlformats.org/presentationml/2006/main">
+<p:sld xmlns:a="http://schemas.openxmlformats.org/drawingml/2006/main" xmlns:p="http://schemas.openxmlformats.org/presentationml/2006/main" xmlns:r="http://schemas.openxmlformats.org/officeDocument/2006/relationships">
   <p:cSld>
     <p:spTree>
       <p:nvGrpSpPr>
@@ -4907,14 +4804,7 @@
         <p:cNvGrpSpPr/>
         <p:nvPr/>
       </p:nvGrpSpPr>
-      <p:grpSpPr>
-        <a:xfrm>
-          <a:off x="0" y="0"/>
-          <a:ext cx="0" cy="0"/>
-          <a:chOff x="0" y="0"/>
-          <a:chExt cx="0" cy="0"/>
-        </a:xfrm>
-      </p:grpSpPr>
+      <p:grpSpPr/>
       <p:sp>
         <p:nvSpPr>
           <p:cNvPr id="2" name="Rectangle 1"/>
@@ -4955,7 +4845,6 @@
           <a:lstStyle/>
           <a:p>
             <a:pPr algn="ctr"/>
-            <a:endParaRPr/>
           </a:p>
         </p:txBody>
       </p:sp>
@@ -5092,7 +4981,6 @@
                 <a:latin typeface="Calibri"/>
               </a:defRPr>
             </a:pPr>
-            <a:endParaRPr/>
           </a:p>
           <a:p>
             <a:pPr>
@@ -5138,7 +5026,6 @@
                 <a:latin typeface="Calibri"/>
               </a:defRPr>
             </a:pPr>
-            <a:endParaRPr/>
           </a:p>
         </p:txBody>
       </p:sp>
@@ -5151,7 +5038,7 @@
 </file>
 
 <file path=ppt/slides/slide5.xml><?xml version="1.0" encoding="utf-8"?>
-<p:sld xmlns:a="http://schemas.openxmlformats.org/drawingml/2006/main" xmlns:r="http://schemas.openxmlformats.org/officeDocument/2006/relationships" xmlns:p="http://schemas.openxmlformats.org/presentationml/2006/main">
+<p:sld xmlns:a="http://schemas.openxmlformats.org/drawingml/2006/main" xmlns:p="http://schemas.openxmlformats.org/presentationml/2006/main" xmlns:r="http://schemas.openxmlformats.org/officeDocument/2006/relationships">
   <p:cSld>
     <p:spTree>
       <p:nvGrpSpPr>
@@ -5159,14 +5046,7 @@
         <p:cNvGrpSpPr/>
         <p:nvPr/>
       </p:nvGrpSpPr>
-      <p:grpSpPr>
-        <a:xfrm>
-          <a:off x="0" y="0"/>
-          <a:ext cx="0" cy="0"/>
-          <a:chOff x="0" y="0"/>
-          <a:chExt cx="0" cy="0"/>
-        </a:xfrm>
-      </p:grpSpPr>
+      <p:grpSpPr/>
       <p:sp>
         <p:nvSpPr>
           <p:cNvPr id="2" name="Rectangle 1"/>
@@ -5207,7 +5087,6 @@
           <a:lstStyle/>
           <a:p>
             <a:pPr algn="ctr"/>
-            <a:endParaRPr/>
           </a:p>
         </p:txBody>
       </p:sp>
@@ -5242,7 +5121,7 @@
               </a:defRPr>
             </a:pPr>
             <a:r>
-              <a:t>Review — LineTrack Methods</a:t>
+              <a:t>Review — Driving Toolkit Functions</a:t>
             </a:r>
           </a:p>
         </p:txBody>
@@ -5281,7 +5160,7 @@
               </a:defRPr>
             </a:pPr>
             <a:r>
-              <a:t>Your LineTrack class from Module 2 has three key methods:</a:t>
+              <a:t>Your driving toolkit from Module 2 has three key functions:</a:t>
             </a:r>
           </a:p>
           <a:p>
@@ -5296,7 +5175,6 @@
                 <a:latin typeface="Calibri"/>
               </a:defRPr>
             </a:pPr>
-            <a:endParaRPr/>
           </a:p>
         </p:txBody>
       </p:sp>
@@ -5308,8 +5186,8 @@
         </p:nvSpPr>
         <p:spPr>
           <a:xfrm>
-            <a:off x="548640" y="1371600"/>
-            <a:ext cx="10972800" cy="2560320"/>
+            <a:off x="548640" y="1645920"/>
+            <a:ext cx="10972800" cy="2103120"/>
           </a:xfrm>
           <a:prstGeom prst="roundRect">
             <a:avLst/>
@@ -5342,7 +5220,6 @@
           <a:lstStyle/>
           <a:p>
             <a:pPr algn="ctr"/>
-            <a:endParaRPr/>
           </a:p>
         </p:txBody>
       </p:sp>
@@ -5354,8 +5231,8 @@
         </p:nvSpPr>
         <p:spPr>
           <a:xfrm>
-            <a:off x="731520" y="1463040"/>
-            <a:ext cx="10607040" cy="2377440"/>
+            <a:off x="731520" y="1737360"/>
+            <a:ext cx="10607040" cy="1920240"/>
           </a:xfrm>
           <a:prstGeom prst="rect">
             <a:avLst/>
@@ -5372,7 +5249,7 @@
               <a:spcAft>
                 <a:spcPts val="100"/>
               </a:spcAft>
-              <a:defRPr sz="1300">
+              <a:defRPr sz="1800">
                 <a:solidFill>
                   <a:srgbClr val="333333"/>
                 </a:solidFill>
@@ -5380,7 +5257,7 @@
               </a:defRPr>
             </a:pPr>
             <a:r>
-              <a:t>tracker = LineTrack()</a:t>
+              <a:t># Follow the line until an intersection</a:t>
             </a:r>
           </a:p>
           <a:p>
@@ -5388,37 +5265,36 @@
               <a:spcAft>
                 <a:spcPts val="100"/>
               </a:spcAft>
-              <a:defRPr sz="1300">
+              <a:defRPr sz="1800">
                 <a:solidFill>
                   <a:srgbClr val="333333"/>
                 </a:solidFill>
                 <a:latin typeface="Courier New"/>
               </a:defRPr>
             </a:pPr>
-            <a:endParaRPr/>
+            <a:r>
+              <a:t>track_until_cross()</a:t>
+            </a:r>
           </a:p>
           <a:p>
             <a:pPr>
               <a:spcAft>
                 <a:spcPts val="100"/>
               </a:spcAft>
-              <a:defRPr sz="1300">
+              <a:defRPr sz="1800">
                 <a:solidFill>
                   <a:srgbClr val="333333"/>
                 </a:solidFill>
                 <a:latin typeface="Courier New"/>
               </a:defRPr>
             </a:pPr>
-            <a:r>
-              <a:t># Follow the line until an intersection</a:t>
-            </a:r>
           </a:p>
           <a:p>
             <a:pPr>
               <a:spcAft>
                 <a:spcPts val="100"/>
               </a:spcAft>
-              <a:defRPr sz="1300">
+              <a:defRPr sz="1800">
                 <a:solidFill>
                   <a:srgbClr val="333333"/>
                 </a:solidFill>
@@ -5426,7 +5302,7 @@
               </a:defRPr>
             </a:pPr>
             <a:r>
-              <a:t>tracker.track_until_cross()</a:t>
+              <a:t># Turn right onto perpendicular line</a:t>
             </a:r>
           </a:p>
           <a:p>
@@ -5434,37 +5310,36 @@
               <a:spcAft>
                 <a:spcPts val="100"/>
               </a:spcAft>
-              <a:defRPr sz="1300">
+              <a:defRPr sz="1800">
                 <a:solidFill>
                   <a:srgbClr val="333333"/>
                 </a:solidFill>
                 <a:latin typeface="Courier New"/>
               </a:defRPr>
             </a:pPr>
-            <a:endParaRPr/>
+            <a:r>
+              <a:t>turn_right()</a:t>
+            </a:r>
           </a:p>
           <a:p>
             <a:pPr>
               <a:spcAft>
                 <a:spcPts val="100"/>
               </a:spcAft>
-              <a:defRPr sz="1300">
+              <a:defRPr sz="1800">
                 <a:solidFill>
                   <a:srgbClr val="333333"/>
                 </a:solidFill>
                 <a:latin typeface="Courier New"/>
               </a:defRPr>
             </a:pPr>
-            <a:r>
-              <a:t># Turn right onto perpendicular line</a:t>
-            </a:r>
           </a:p>
           <a:p>
             <a:pPr>
               <a:spcAft>
                 <a:spcPts val="100"/>
               </a:spcAft>
-              <a:defRPr sz="1300">
+              <a:defRPr sz="1800">
                 <a:solidFill>
                   <a:srgbClr val="333333"/>
                 </a:solidFill>
@@ -5472,7 +5347,7 @@
               </a:defRPr>
             </a:pPr>
             <a:r>
-              <a:t>tracker.turn_right()</a:t>
+              <a:t># Turn left onto perpendicular line</a:t>
             </a:r>
           </a:p>
           <a:p>
@@ -5480,45 +5355,15 @@
               <a:spcAft>
                 <a:spcPts val="100"/>
               </a:spcAft>
-              <a:defRPr sz="1300">
+              <a:defRPr sz="1800">
                 <a:solidFill>
                   <a:srgbClr val="333333"/>
                 </a:solidFill>
                 <a:latin typeface="Courier New"/>
               </a:defRPr>
             </a:pPr>
-            <a:endParaRPr/>
-          </a:p>
-          <a:p>
-            <a:pPr>
-              <a:spcAft>
-                <a:spcPts val="100"/>
-              </a:spcAft>
-              <a:defRPr sz="1300">
-                <a:solidFill>
-                  <a:srgbClr val="333333"/>
-                </a:solidFill>
-                <a:latin typeface="Courier New"/>
-              </a:defRPr>
-            </a:pPr>
-            <a:r>
-              <a:t># Turn left onto perpendicular line</a:t>
-            </a:r>
-          </a:p>
-          <a:p>
-            <a:pPr>
-              <a:spcAft>
-                <a:spcPts val="100"/>
-              </a:spcAft>
-              <a:defRPr sz="1300">
-                <a:solidFill>
-                  <a:srgbClr val="333333"/>
-                </a:solidFill>
-                <a:latin typeface="Courier New"/>
-              </a:defRPr>
-            </a:pPr>
-            <a:r>
-              <a:t>tracker.turn_left()</a:t>
+            <a:r>
+              <a:t>turn_left()</a:t>
             </a:r>
           </a:p>
         </p:txBody>
@@ -5531,7 +5376,7 @@
         </p:nvSpPr>
         <p:spPr>
           <a:xfrm>
-            <a:off x="548640" y="4069080"/>
+            <a:off x="548640" y="3886200"/>
             <a:ext cx="10972800" cy="365760"/>
           </a:xfrm>
           <a:prstGeom prst="rect">
@@ -5572,7 +5417,6 @@
                 <a:latin typeface="Calibri"/>
               </a:defRPr>
             </a:pPr>
-            <a:endParaRPr/>
           </a:p>
         </p:txBody>
       </p:sp>
@@ -5585,7 +5429,7 @@
 </file>
 
 <file path=ppt/slides/slide6.xml><?xml version="1.0" encoding="utf-8"?>
-<p:sld xmlns:a="http://schemas.openxmlformats.org/drawingml/2006/main" xmlns:r="http://schemas.openxmlformats.org/officeDocument/2006/relationships" xmlns:p="http://schemas.openxmlformats.org/presentationml/2006/main">
+<p:sld xmlns:a="http://schemas.openxmlformats.org/drawingml/2006/main" xmlns:p="http://schemas.openxmlformats.org/presentationml/2006/main" xmlns:r="http://schemas.openxmlformats.org/officeDocument/2006/relationships">
   <p:cSld>
     <p:spTree>
       <p:nvGrpSpPr>
@@ -5593,14 +5437,7 @@
         <p:cNvGrpSpPr/>
         <p:nvPr/>
       </p:nvGrpSpPr>
-      <p:grpSpPr>
-        <a:xfrm>
-          <a:off x="0" y="0"/>
-          <a:ext cx="0" cy="0"/>
-          <a:chOff x="0" y="0"/>
-          <a:chExt cx="0" cy="0"/>
-        </a:xfrm>
-      </p:grpSpPr>
+      <p:grpSpPr/>
       <p:sp>
         <p:nvSpPr>
           <p:cNvPr id="2" name="Rectangle 1"/>
@@ -5641,7 +5478,6 @@
           <a:lstStyle/>
           <a:p>
             <a:pPr algn="ctr"/>
-            <a:endParaRPr/>
           </a:p>
         </p:txBody>
       </p:sp>
@@ -5742,7 +5578,7 @@
         <p:spPr>
           <a:xfrm>
             <a:off x="548640" y="1920240"/>
-            <a:ext cx="5669280" cy="1874519"/>
+            <a:ext cx="5669280" cy="1645920"/>
           </a:xfrm>
           <a:prstGeom prst="roundRect">
             <a:avLst/>
@@ -5775,7 +5611,6 @@
           <a:lstStyle/>
           <a:p>
             <a:pPr algn="ctr"/>
-            <a:endParaRPr/>
           </a:p>
         </p:txBody>
       </p:sp>
@@ -5788,7 +5623,7 @@
         <p:spPr>
           <a:xfrm>
             <a:off x="731520" y="2011680"/>
-            <a:ext cx="5303520" cy="1691639"/>
+            <a:ext cx="5303520" cy="1463040"/>
           </a:xfrm>
           <a:prstGeom prst="rect">
             <a:avLst/>
@@ -5805,7 +5640,7 @@
               <a:spcAft>
                 <a:spcPts val="100"/>
               </a:spcAft>
-              <a:defRPr sz="1300">
+              <a:defRPr sz="1800">
                 <a:solidFill>
                   <a:srgbClr val="333333"/>
                 </a:solidFill>
@@ -5821,37 +5656,36 @@
               <a:spcAft>
                 <a:spcPts val="100"/>
               </a:spcAft>
-              <a:defRPr sz="1300">
+              <a:defRPr sz="1800">
                 <a:solidFill>
                   <a:srgbClr val="333333"/>
                 </a:solidFill>
                 <a:latin typeface="Courier New"/>
               </a:defRPr>
             </a:pPr>
-            <a:r>
-              <a:t>tracker = LineTrack()</a:t>
-            </a:r>
           </a:p>
           <a:p>
             <a:pPr>
               <a:spcAft>
                 <a:spcPts val="100"/>
               </a:spcAft>
-              <a:defRPr sz="1300">
+              <a:defRPr sz="1800">
                 <a:solidFill>
                   <a:srgbClr val="333333"/>
                 </a:solidFill>
                 <a:latin typeface="Courier New"/>
               </a:defRPr>
             </a:pPr>
-            <a:endParaRPr/>
+            <a:r>
+              <a:t>board.wait_for_button()</a:t>
+            </a:r>
           </a:p>
           <a:p>
             <a:pPr>
               <a:spcAft>
                 <a:spcPts val="100"/>
               </a:spcAft>
-              <a:defRPr sz="1300">
+              <a:defRPr sz="1800">
                 <a:solidFill>
                   <a:srgbClr val="333333"/>
                 </a:solidFill>
@@ -5859,7 +5693,7 @@
               </a:defRPr>
             </a:pPr>
             <a:r>
-              <a:t>board.wait_for_button()</a:t>
+              <a:t>print("Driving to first intersection...")</a:t>
             </a:r>
           </a:p>
           <a:p>
@@ -5867,7 +5701,7 @@
               <a:spcAft>
                 <a:spcPts val="100"/>
               </a:spcAft>
-              <a:defRPr sz="1300">
+              <a:defRPr sz="1800">
                 <a:solidFill>
                   <a:srgbClr val="333333"/>
                 </a:solidFill>
@@ -5875,7 +5709,7 @@
               </a:defRPr>
             </a:pPr>
             <a:r>
-              <a:t>print("Driving to first intersection...")</a:t>
+              <a:t>track_until_cross()</a:t>
             </a:r>
           </a:p>
           <a:p>
@@ -5883,23 +5717,7 @@
               <a:spcAft>
                 <a:spcPts val="100"/>
               </a:spcAft>
-              <a:defRPr sz="1300">
-                <a:solidFill>
-                  <a:srgbClr val="333333"/>
-                </a:solidFill>
-                <a:latin typeface="Courier New"/>
-              </a:defRPr>
-            </a:pPr>
-            <a:r>
-              <a:t>tracker.track_until_cross()</a:t>
-            </a:r>
-          </a:p>
-          <a:p>
-            <a:pPr>
-              <a:spcAft>
-                <a:spcPts val="100"/>
-              </a:spcAft>
-              <a:defRPr sz="1300">
+              <a:defRPr sz="1800">
                 <a:solidFill>
                   <a:srgbClr val="333333"/>
                 </a:solidFill>
@@ -5921,7 +5739,7 @@
         <p:spPr>
           <a:xfrm>
             <a:off x="6583680" y="1920240"/>
-            <a:ext cx="5029200" cy="1874519"/>
+            <a:ext cx="5029200" cy="1645920"/>
           </a:xfrm>
           <a:prstGeom prst="rect">
             <a:avLst/>
@@ -6005,7 +5823,7 @@
 </file>
 
 <file path=ppt/slides/slide7.xml><?xml version="1.0" encoding="utf-8"?>
-<p:sld xmlns:a="http://schemas.openxmlformats.org/drawingml/2006/main" xmlns:r="http://schemas.openxmlformats.org/officeDocument/2006/relationships" xmlns:p="http://schemas.openxmlformats.org/presentationml/2006/main">
+<p:sld xmlns:a="http://schemas.openxmlformats.org/drawingml/2006/main" xmlns:p="http://schemas.openxmlformats.org/presentationml/2006/main" xmlns:r="http://schemas.openxmlformats.org/officeDocument/2006/relationships">
   <p:cSld>
     <p:spTree>
       <p:nvGrpSpPr>
@@ -6013,14 +5831,7 @@
         <p:cNvGrpSpPr/>
         <p:nvPr/>
       </p:nvGrpSpPr>
-      <p:grpSpPr>
-        <a:xfrm>
-          <a:off x="0" y="0"/>
-          <a:ext cx="0" cy="0"/>
-          <a:chOff x="0" y="0"/>
-          <a:chExt cx="0" cy="0"/>
-        </a:xfrm>
-      </p:grpSpPr>
+      <p:grpSpPr/>
       <p:sp>
         <p:nvSpPr>
           <p:cNvPr id="2" name="Rectangle 1"/>
@@ -6061,7 +5872,6 @@
           <a:lstStyle/>
           <a:p>
             <a:pPr algn="ctr"/>
-            <a:endParaRPr/>
           </a:p>
         </p:txBody>
       </p:sp>
@@ -6145,7 +5955,7 @@
         </p:nvSpPr>
         <p:spPr>
           <a:xfrm>
-            <a:off x="396240" y="1911734"/>
+            <a:off x="548640" y="1645920"/>
             <a:ext cx="5669280" cy="2560320"/>
           </a:xfrm>
           <a:prstGeom prst="roundRect">
@@ -6179,7 +5989,6 @@
           <a:lstStyle/>
           <a:p>
             <a:pPr algn="ctr"/>
-            <a:endParaRPr/>
           </a:p>
         </p:txBody>
       </p:sp>
@@ -6191,7 +6000,7 @@
         </p:nvSpPr>
         <p:spPr>
           <a:xfrm>
-            <a:off x="579120" y="2003174"/>
+            <a:off x="731520" y="1737360"/>
             <a:ext cx="5303520" cy="2377440"/>
           </a:xfrm>
           <a:prstGeom prst="rect">
@@ -6209,7 +6018,7 @@
               <a:spcAft>
                 <a:spcPts val="100"/>
               </a:spcAft>
-              <a:defRPr sz="1300">
+              <a:defRPr sz="1800">
                 <a:solidFill>
                   <a:srgbClr val="333333"/>
                 </a:solidFill>
@@ -6217,12 +6026,7 @@
               </a:defRPr>
             </a:pPr>
             <a:r>
-              <a:rPr dirty="0" err="1"/>
-              <a:t>board.wait_for_button</a:t>
-            </a:r>
-            <a:r>
-              <a:rPr dirty="0"/>
-              <a:t>()</a:t>
+              <a:t>board.wait_for_button()</a:t>
             </a:r>
           </a:p>
           <a:p>
@@ -6230,21 +6034,20 @@
               <a:spcAft>
                 <a:spcPts val="100"/>
               </a:spcAft>
-              <a:defRPr sz="1300">
+              <a:defRPr sz="1800">
                 <a:solidFill>
                   <a:srgbClr val="333333"/>
                 </a:solidFill>
                 <a:latin typeface="Courier New"/>
               </a:defRPr>
             </a:pPr>
-            <a:endParaRPr dirty="0"/>
           </a:p>
           <a:p>
             <a:pPr>
               <a:spcAft>
                 <a:spcPts val="100"/>
               </a:spcAft>
-              <a:defRPr sz="1300">
+              <a:defRPr sz="1800">
                 <a:solidFill>
                   <a:srgbClr val="333333"/>
                 </a:solidFill>
@@ -6252,12 +6055,7 @@
               </a:defRPr>
             </a:pPr>
             <a:r>
-              <a:rPr dirty="0" err="1"/>
-              <a:t>tracker.track_until_cross</a:t>
-            </a:r>
-            <a:r>
-              <a:rPr dirty="0"/>
-              <a:t>()</a:t>
+              <a:t>track_until_cross()</a:t>
             </a:r>
           </a:p>
           <a:p>
@@ -6265,7 +6063,7 @@
               <a:spcAft>
                 <a:spcPts val="100"/>
               </a:spcAft>
-              <a:defRPr sz="1300">
+              <a:defRPr sz="1800">
                 <a:solidFill>
                   <a:srgbClr val="333333"/>
                 </a:solidFill>
@@ -6273,7 +6071,6 @@
               </a:defRPr>
             </a:pPr>
             <a:r>
-              <a:rPr dirty="0"/>
               <a:t>print("At intersection!")</a:t>
             </a:r>
           </a:p>
@@ -6282,21 +6079,20 @@
               <a:spcAft>
                 <a:spcPts val="100"/>
               </a:spcAft>
-              <a:defRPr sz="1300">
+              <a:defRPr sz="1800">
                 <a:solidFill>
                   <a:srgbClr val="333333"/>
                 </a:solidFill>
                 <a:latin typeface="Courier New"/>
               </a:defRPr>
             </a:pPr>
-            <a:endParaRPr dirty="0"/>
           </a:p>
           <a:p>
             <a:pPr>
               <a:spcAft>
                 <a:spcPts val="100"/>
               </a:spcAft>
-              <a:defRPr sz="1300">
+              <a:defRPr sz="1800">
                 <a:solidFill>
                   <a:srgbClr val="333333"/>
                 </a:solidFill>
@@ -6304,12 +6100,7 @@
               </a:defRPr>
             </a:pPr>
             <a:r>
-              <a:rPr dirty="0" err="1"/>
-              <a:t>tracker.turn_right</a:t>
-            </a:r>
-            <a:r>
-              <a:rPr dirty="0"/>
-              <a:t>()</a:t>
+              <a:t>turn_right()</a:t>
             </a:r>
           </a:p>
           <a:p>
@@ -6317,7 +6108,7 @@
               <a:spcAft>
                 <a:spcPts val="100"/>
               </a:spcAft>
-              <a:defRPr sz="1300">
+              <a:defRPr sz="1800">
                 <a:solidFill>
                   <a:srgbClr val="333333"/>
                 </a:solidFill>
@@ -6325,7 +6116,6 @@
               </a:defRPr>
             </a:pPr>
             <a:r>
-              <a:rPr dirty="0"/>
               <a:t>print("Turned right - now on perpendicular line!")</a:t>
             </a:r>
           </a:p>
@@ -6334,21 +6124,20 @@
               <a:spcAft>
                 <a:spcPts val="100"/>
               </a:spcAft>
-              <a:defRPr sz="1300">
+              <a:defRPr sz="1800">
                 <a:solidFill>
                   <a:srgbClr val="333333"/>
                 </a:solidFill>
                 <a:latin typeface="Courier New"/>
               </a:defRPr>
             </a:pPr>
-            <a:endParaRPr dirty="0"/>
           </a:p>
           <a:p>
             <a:pPr>
               <a:spcAft>
                 <a:spcPts val="100"/>
               </a:spcAft>
-              <a:defRPr sz="1300">
+              <a:defRPr sz="1800">
                 <a:solidFill>
                   <a:srgbClr val="333333"/>
                 </a:solidFill>
@@ -6356,12 +6145,7 @@
               </a:defRPr>
             </a:pPr>
             <a:r>
-              <a:rPr dirty="0" err="1"/>
-              <a:t>tracker.track_until_cross</a:t>
-            </a:r>
-            <a:r>
-              <a:rPr dirty="0"/>
-              <a:t>()</a:t>
+              <a:t>track_until_cross()</a:t>
             </a:r>
           </a:p>
           <a:p>
@@ -6369,7 +6153,7 @@
               <a:spcAft>
                 <a:spcPts val="100"/>
               </a:spcAft>
-              <a:defRPr sz="1300">
+              <a:defRPr sz="1800">
                 <a:solidFill>
                   <a:srgbClr val="333333"/>
                 </a:solidFill>
@@ -6377,7 +6161,6 @@
               </a:defRPr>
             </a:pPr>
             <a:r>
-              <a:rPr dirty="0"/>
               <a:t>print("At next intersection!")</a:t>
             </a:r>
           </a:p>
@@ -6476,7 +6259,7 @@
 </file>
 
 <file path=ppt/slides/slide8.xml><?xml version="1.0" encoding="utf-8"?>
-<p:sld xmlns:a="http://schemas.openxmlformats.org/drawingml/2006/main" xmlns:r="http://schemas.openxmlformats.org/officeDocument/2006/relationships" xmlns:p="http://schemas.openxmlformats.org/presentationml/2006/main">
+<p:sld xmlns:a="http://schemas.openxmlformats.org/drawingml/2006/main" xmlns:p="http://schemas.openxmlformats.org/presentationml/2006/main" xmlns:r="http://schemas.openxmlformats.org/officeDocument/2006/relationships">
   <p:cSld>
     <p:spTree>
       <p:nvGrpSpPr>
@@ -6484,14 +6267,7 @@
         <p:cNvGrpSpPr/>
         <p:nvPr/>
       </p:nvGrpSpPr>
-      <p:grpSpPr>
-        <a:xfrm>
-          <a:off x="0" y="0"/>
-          <a:ext cx="0" cy="0"/>
-          <a:chOff x="0" y="0"/>
-          <a:chExt cx="0" cy="0"/>
-        </a:xfrm>
-      </p:grpSpPr>
+      <p:grpSpPr/>
       <p:sp>
         <p:nvSpPr>
           <p:cNvPr id="2" name="Rectangle 1"/>
@@ -6532,7 +6308,6 @@
           <a:lstStyle/>
           <a:p>
             <a:pPr algn="ctr"/>
-            <a:endParaRPr/>
           </a:p>
         </p:txBody>
       </p:sp>
@@ -6621,7 +6396,6 @@
                 <a:latin typeface="Calibri"/>
               </a:defRPr>
             </a:pPr>
-            <a:endParaRPr/>
           </a:p>
         </p:txBody>
       </p:sp>
@@ -6631,16 +6405,10 @@
           <p:cNvGraphicFramePr>
             <a:graphicFrameLocks noGrp="1"/>
           </p:cNvGraphicFramePr>
-          <p:nvPr>
-            <p:extLst>
-              <p:ext uri="{D42A27DB-BD31-4B8C-83A1-F6EECF244321}">
-                <p14:modId xmlns:p14="http://schemas.microsoft.com/office/powerpoint/2010/main" val="1434195210"/>
-              </p:ext>
-            </p:extLst>
-          </p:nvPr>
+          <p:nvPr/>
         </p:nvGraphicFramePr>
         <p:xfrm>
-          <a:off x="548640" y="1917050"/>
+          <a:off x="914400" y="1371600"/>
           <a:ext cx="10058400" cy="2194560"/>
         </p:xfrm>
         <a:graphic>
@@ -6650,20 +6418,8 @@
                 <a:tableStyleId>{5C22544A-7EE6-4342-B048-85BDC9FD1C3A}</a:tableStyleId>
               </a:tblPr>
               <a:tblGrid>
-                <a:gridCol w="5029200">
-                  <a:extLst>
-                    <a:ext uri="{9D8B030D-6E8A-4147-A177-3AD203B41FA5}">
-                      <a16:colId xmlns:a16="http://schemas.microsoft.com/office/drawing/2014/main" val="20000"/>
-                    </a:ext>
-                  </a:extLst>
-                </a:gridCol>
-                <a:gridCol w="5029200">
-                  <a:extLst>
-                    <a:ext uri="{9D8B030D-6E8A-4147-A177-3AD203B41FA5}">
-                      <a16:colId xmlns:a16="http://schemas.microsoft.com/office/drawing/2014/main" val="20001"/>
-                    </a:ext>
-                  </a:extLst>
-                </a:gridCol>
+                <a:gridCol w="5029200"/>
+                <a:gridCol w="5029200"/>
               </a:tblGrid>
               <a:tr h="365760">
                 <a:tc>
@@ -6680,7 +6436,6 @@
                         </a:defRPr>
                       </a:pPr>
                       <a:r>
-                        <a:rPr dirty="0"/>
                         <a:t>Module 2</a:t>
                       </a:r>
                     </a:p>
@@ -6715,11 +6470,6 @@
                     </a:solidFill>
                   </a:tcPr>
                 </a:tc>
-                <a:extLst>
-                  <a:ext uri="{0D108BD9-81ED-4DB2-BD59-A6C34878D82A}">
-                    <a16:rowId xmlns:a16="http://schemas.microsoft.com/office/drawing/2014/main" val="10000"/>
-                  </a:ext>
-                </a:extLst>
               </a:tr>
               <a:tr h="365760">
                 <a:tc>
@@ -6756,11 +6506,6 @@
                   </a:txBody>
                   <a:tcPr/>
                 </a:tc>
-                <a:extLst>
-                  <a:ext uri="{0D108BD9-81ED-4DB2-BD59-A6C34878D82A}">
-                    <a16:rowId xmlns:a16="http://schemas.microsoft.com/office/drawing/2014/main" val="10001"/>
-                  </a:ext>
-                </a:extLst>
               </a:tr>
               <a:tr h="365760">
                 <a:tc>
@@ -6805,11 +6550,6 @@
                     </a:solidFill>
                   </a:tcPr>
                 </a:tc>
-                <a:extLst>
-                  <a:ext uri="{0D108BD9-81ED-4DB2-BD59-A6C34878D82A}">
-                    <a16:rowId xmlns:a16="http://schemas.microsoft.com/office/drawing/2014/main" val="10002"/>
-                  </a:ext>
-                </a:extLst>
               </a:tr>
               <a:tr h="365760">
                 <a:tc>
@@ -6846,11 +6586,6 @@
                   </a:txBody>
                   <a:tcPr/>
                 </a:tc>
-                <a:extLst>
-                  <a:ext uri="{0D108BD9-81ED-4DB2-BD59-A6C34878D82A}">
-                    <a16:rowId xmlns:a16="http://schemas.microsoft.com/office/drawing/2014/main" val="10003"/>
-                  </a:ext>
-                </a:extLst>
               </a:tr>
               <a:tr h="365760">
                 <a:tc>
@@ -6864,7 +6599,7 @@
                         </a:defRPr>
                       </a:pPr>
                       <a:r>
-                        <a:t>track_until_cross()</a:t>
+                        <a:t>`track_until_cross()`</a:t>
                       </a:r>
                     </a:p>
                   </a:txBody>
@@ -6895,11 +6630,6 @@
                     </a:solidFill>
                   </a:tcPr>
                 </a:tc>
-                <a:extLst>
-                  <a:ext uri="{0D108BD9-81ED-4DB2-BD59-A6C34878D82A}">
-                    <a16:rowId xmlns:a16="http://schemas.microsoft.com/office/drawing/2014/main" val="10004"/>
-                  </a:ext>
-                </a:extLst>
               </a:tr>
               <a:tr h="365760">
                 <a:tc>
@@ -6913,7 +6643,7 @@
                         </a:defRPr>
                       </a:pPr>
                       <a:r>
-                        <a:t>turn_right()</a:t>
+                        <a:t>`turn_right()`</a:t>
                       </a:r>
                     </a:p>
                   </a:txBody>
@@ -6930,18 +6660,12 @@
                         </a:defRPr>
                       </a:pPr>
                       <a:r>
-                        <a:rPr dirty="0"/>
                         <a:t>Same method, same code!</a:t>
                       </a:r>
                     </a:p>
                   </a:txBody>
                   <a:tcPr/>
                 </a:tc>
-                <a:extLst>
-                  <a:ext uri="{0D108BD9-81ED-4DB2-BD59-A6C34878D82A}">
-                    <a16:rowId xmlns:a16="http://schemas.microsoft.com/office/drawing/2014/main" val="10005"/>
-                  </a:ext>
-                </a:extLst>
               </a:tr>
             </a:tbl>
           </a:graphicData>
@@ -6955,7 +6679,7 @@
         </p:nvSpPr>
         <p:spPr>
           <a:xfrm>
-            <a:off x="548640" y="4291300"/>
+            <a:off x="548640" y="3749040"/>
             <a:ext cx="10972800" cy="365760"/>
           </a:xfrm>
           <a:prstGeom prst="rect">
@@ -6981,7 +6705,6 @@
               </a:defRPr>
             </a:pPr>
             <a:r>
-              <a:rPr dirty="0"/>
               <a:t>Key insight: Good code works in new situations without modification.</a:t>
             </a:r>
           </a:p>
@@ -6997,7 +6720,6 @@
                 <a:latin typeface="Calibri"/>
               </a:defRPr>
             </a:pPr>
-            <a:endParaRPr dirty="0"/>
           </a:p>
         </p:txBody>
       </p:sp>
@@ -7010,7 +6732,7 @@
 </file>
 
 <file path=ppt/slides/slide9.xml><?xml version="1.0" encoding="utf-8"?>
-<p:sld xmlns:a="http://schemas.openxmlformats.org/drawingml/2006/main" xmlns:r="http://schemas.openxmlformats.org/officeDocument/2006/relationships" xmlns:p="http://schemas.openxmlformats.org/presentationml/2006/main">
+<p:sld xmlns:a="http://schemas.openxmlformats.org/drawingml/2006/main" xmlns:p="http://schemas.openxmlformats.org/presentationml/2006/main" xmlns:r="http://schemas.openxmlformats.org/officeDocument/2006/relationships">
   <p:cSld>
     <p:spTree>
       <p:nvGrpSpPr>
@@ -7018,14 +6740,7 @@
         <p:cNvGrpSpPr/>
         <p:nvPr/>
       </p:nvGrpSpPr>
-      <p:grpSpPr>
-        <a:xfrm>
-          <a:off x="0" y="0"/>
-          <a:ext cx="0" cy="0"/>
-          <a:chOff x="0" y="0"/>
-          <a:chExt cx="0" cy="0"/>
-        </a:xfrm>
-      </p:grpSpPr>
+      <p:grpSpPr/>
       <p:sp>
         <p:nvSpPr>
           <p:cNvPr id="2" name="Rectangle 1"/>
@@ -7066,7 +6781,6 @@
           <a:lstStyle/>
           <a:p>
             <a:pPr algn="ctr"/>
-            <a:endParaRPr/>
           </a:p>
         </p:txBody>
       </p:sp>
@@ -7156,7 +6870,7 @@
               </a:defRPr>
             </a:pPr>
             <a:r>
-              <a:t>Copy your LineSensor and LineTrack classes from Module 2</a:t>
+              <a:t>Copy your sensor and driving toolkits from Module 2</a:t>
             </a:r>
           </a:p>
           <a:p>
@@ -7235,7 +6949,6 @@
                 <a:latin typeface="Calibri"/>
               </a:defRPr>
             </a:pPr>
-            <a:endParaRPr/>
           </a:p>
           <a:p>
             <a:pPr>
@@ -7313,7 +7026,6 @@
                 <a:latin typeface="Calibri"/>
               </a:defRPr>
             </a:pPr>
-            <a:endParaRPr/>
           </a:p>
         </p:txBody>
       </p:sp>

</xml_diff>